<commit_message>
Fusion deck: add slide 4 (findings and value)
Co-Authored-By: Claude Opus 5.5 (1M context) <noreply@anthropic.com>
</commit_message>
<xml_diff>
--- a/results/fusion_slides_2026-10.pptx
+++ b/results/fusion_slides_2026-10.pptx
@@ -8,9 +8,10 @@
     <p:sldId id="256" r:id="rId2"/>
     <p:sldId id="257" r:id="rId3"/>
     <p:sldId id="258" r:id="rId4"/>
+    <p:sldId id="259" r:id="rId5"/>
   </p:sldIdLst>
   <p:notesMasterIdLst>
-    <p:notesMasterId r:id="rId5"/>
+    <p:notesMasterId r:id="rId6"/>
   </p:notesMasterIdLst>
   <p:sldSz cx="12192000" cy="6858000"/>
   <p:notesSz cx="6858000" cy="12192000"/>
@@ -1196,6 +1197,96 @@
 </p:notes>
 </file>
 
+<file path=ppt/notesSlides/notesSlide4.xml><?xml version="1.0" encoding="utf-8"?>
+<p:notes xmlns:a="http://schemas.openxmlformats.org/drawingml/2006/main" xmlns:r="http://schemas.openxmlformats.org/officeDocument/2006/relationships" xmlns:p="http://schemas.openxmlformats.org/presentationml/2006/main">
+  <p:cSld>
+    <p:spTree>
+      <p:nvGrpSpPr>
+        <p:cNvPr id="1" name=""/>
+        <p:cNvGrpSpPr/>
+        <p:nvPr/>
+      </p:nvGrpSpPr>
+      <p:grpSpPr>
+        <a:xfrm>
+          <a:off x="0" y="0"/>
+          <a:ext cx="0" cy="0"/>
+          <a:chOff x="0" y="0"/>
+          <a:chExt cx="0" cy="0"/>
+        </a:xfrm>
+      </p:grpSpPr>
+      <p:sp>
+        <p:nvSpPr>
+          <p:cNvPr id="2" name="Slide Image Placeholder 1"/>
+          <p:cNvSpPr>
+            <a:spLocks noGrp="1" noRot="1" noChangeAspect="1"/>
+          </p:cNvSpPr>
+          <p:nvPr>
+            <p:ph type="sldImg"/>
+          </p:nvPr>
+        </p:nvSpPr>
+        <p:spPr/>
+      </p:sp>
+      <p:sp>
+        <p:nvSpPr>
+          <p:cNvPr id="3" name="Notes Placeholder 2"/>
+          <p:cNvSpPr>
+            <a:spLocks noGrp="1"/>
+          </p:cNvSpPr>
+          <p:nvPr>
+            <p:ph type="body" idx="1"/>
+          </p:nvPr>
+        </p:nvSpPr>
+        <p:spPr/>
+        <p:txBody>
+          <a:bodyPr/>
+          <a:lstStyle/>
+          <a:p>
+            <a:r>
+              <a:rPr lang="en-US" dirty="0"/>
+              <a:t>【台本】（約40秒）
+この研究で分かったことは3つです。1つ目、Whisper の損失で学習した音声強調は、作りの違う認識器では逆に悪くなります。2つ目、事前学習済みの生成モデルは、どの認識器でも効きます。3つ目、Whisper に効いているのは声の大まかな形で、悪影響は喉マイクに元々無い高い音から来ています。
+価値としては、クラウドのように中身を変えられない Whisper 系の認識器でも、前処理だけで誤りを 26〜37% 減らせることです。また、欠けた音は生成で補い、Whisper 向けの調整は外側で控えめに足す、という設計の指針になります。一方で、別の機種の喉マイクではそのままでは効かないという限界も分かりました。</a:t>
+            </a:r>
+            <a:endParaRPr lang="en-US" dirty="0"/>
+          </a:p>
+        </p:txBody>
+      </p:sp>
+      <p:sp>
+        <p:nvSpPr>
+          <p:cNvPr id="4" name="Slide Number Placeholder 3"/>
+          <p:cNvSpPr>
+            <a:spLocks noGrp="1"/>
+          </p:cNvSpPr>
+          <p:nvPr>
+            <p:ph type="sldNum" sz="quarter" idx="10"/>
+          </p:nvPr>
+        </p:nvSpPr>
+        <p:spPr/>
+        <p:txBody>
+          <a:bodyPr/>
+          <a:lstStyle/>
+          <a:p>
+            <a:fld id="{F7021451-1387-4CA6-816F-3879F97B5CBC}" type="slidenum">
+              <a:rPr lang="en-US"/>
+              <a:t>4</a:t>
+            </a:fld>
+            <a:endParaRPr lang="en-US"/>
+          </a:p>
+        </p:txBody>
+      </p:sp>
+    </p:spTree>
+    <p:extLst>
+      <p:ext uri="{BB962C8B-B14F-4D97-AF65-F5344CB8AC3E}">
+        <p14:creationId xmlns:p14="http://schemas.microsoft.com/office/powerpoint/2010/main" val="1024086991"/>
+      </p:ext>
+    </p:extLst>
+  </p:cSld>
+  <p:clrMapOvr>
+    <a:masterClrMapping/>
+  </p:clrMapOvr>
+</p:notes>
+</file>
+
 <file path=ppt/slideLayouts/slideLayout1.xml><?xml version="1.0" encoding="utf-8"?>
 <p:sldLayout xmlns:a="http://schemas.openxmlformats.org/drawingml/2006/main" xmlns:r="http://schemas.openxmlformats.org/officeDocument/2006/relationships" xmlns:p="http://schemas.openxmlformats.org/presentationml/2006/main" preserve="1">
   <p:cSld name="DEFAULT">
@@ -4148,6 +4239,622 @@
 </p:sld>
 </file>
 
+<file path=ppt/slides/slide4.xml><?xml version="1.0" encoding="utf-8"?>
+<p:sld xmlns:a="http://schemas.openxmlformats.org/drawingml/2006/main" xmlns:r="http://schemas.openxmlformats.org/officeDocument/2006/relationships" xmlns:p="http://schemas.openxmlformats.org/presentationml/2006/main">
+  <p:cSld name="Slide 4">
+    <p:bg>
+      <p:bgPr>
+        <a:solidFill>
+          <a:srgbClr val="FFFFFF"/>
+        </a:solidFill>
+      </p:bgPr>
+    </p:bg>
+    <p:spTree>
+      <p:nvGrpSpPr>
+        <p:cNvPr id="1" name=""/>
+        <p:cNvGrpSpPr/>
+        <p:nvPr/>
+      </p:nvGrpSpPr>
+      <p:grpSpPr>
+        <a:xfrm>
+          <a:off x="0" y="0"/>
+          <a:ext cx="0" cy="0"/>
+          <a:chOff x="0" y="0"/>
+          <a:chExt cx="0" cy="0"/>
+        </a:xfrm>
+      </p:grpSpPr>
+      <p:sp>
+        <p:nvSpPr>
+          <p:cNvPr id="2" name="Text 0"/>
+          <p:cNvSpPr/>
+          <p:nvPr/>
+        </p:nvSpPr>
+        <p:spPr>
+          <a:xfrm>
+            <a:off x="548640" y="365760"/>
+            <a:ext cx="11094415" cy="914400"/>
+          </a:xfrm>
+          <a:prstGeom prst="rect">
+            <a:avLst/>
+          </a:prstGeom>
+          <a:noFill/>
+          <a:ln/>
+        </p:spPr>
+        <p:txBody>
+          <a:bodyPr wrap="square" lIns="0" tIns="0" rIns="0" bIns="0" rtlCol="0" anchor="ctr"/>
+          <a:lstStyle/>
+          <a:p>
+            <a:pPr indent="0" marL="0">
+              <a:buNone/>
+            </a:pPr>
+            <a:r>
+              <a:rPr lang="en-US" sz="2800" b="1" dirty="0">
+                <a:solidFill>
+                  <a:srgbClr val="1F4E79"/>
+                </a:solidFill>
+                <a:latin typeface="Yu Gothic" pitchFamily="34" charset="0"/>
+                <a:ea typeface="Yu Gothic" pitchFamily="34" charset="-122"/>
+                <a:cs typeface="Yu Gothic" pitchFamily="34" charset="-120"/>
+              </a:rPr>
+              <a:t>欠けた音の補完と Whisper への合わせ込みは、分けて設計できる</a:t>
+            </a:r>
+            <a:endParaRPr lang="en-US" sz="2800" dirty="0"/>
+          </a:p>
+        </p:txBody>
+      </p:sp>
+      <p:sp>
+        <p:nvSpPr>
+          <p:cNvPr id="3" name="Text 1"/>
+          <p:cNvSpPr/>
+          <p:nvPr/>
+        </p:nvSpPr>
+        <p:spPr>
+          <a:xfrm>
+            <a:off x="548640" y="1463040"/>
+            <a:ext cx="5486400" cy="411480"/>
+          </a:xfrm>
+          <a:prstGeom prst="rect">
+            <a:avLst/>
+          </a:prstGeom>
+          <a:noFill/>
+          <a:ln/>
+        </p:spPr>
+        <p:txBody>
+          <a:bodyPr wrap="square" lIns="0" tIns="0" rIns="0" bIns="0" rtlCol="0" anchor="t"/>
+          <a:lstStyle/>
+          <a:p>
+            <a:pPr indent="0" marL="0">
+              <a:buNone/>
+            </a:pPr>
+            <a:r>
+              <a:rPr lang="en-US" sz="2000" b="1" dirty="0">
+                <a:solidFill>
+                  <a:srgbClr val="1F4E79"/>
+                </a:solidFill>
+                <a:latin typeface="Yu Gothic" pitchFamily="34" charset="0"/>
+                <a:ea typeface="Yu Gothic" pitchFamily="34" charset="-122"/>
+                <a:cs typeface="Yu Gothic" pitchFamily="34" charset="-120"/>
+              </a:rPr>
+              <a:t>分かったこと</a:t>
+            </a:r>
+            <a:endParaRPr lang="en-US" sz="2000" dirty="0"/>
+          </a:p>
+        </p:txBody>
+      </p:sp>
+      <p:sp>
+        <p:nvSpPr>
+          <p:cNvPr id="4" name="Text 2"/>
+          <p:cNvSpPr/>
+          <p:nvPr/>
+        </p:nvSpPr>
+        <p:spPr>
+          <a:xfrm>
+            <a:off x="548640" y="1965960"/>
+            <a:ext cx="5486400" cy="3291840"/>
+          </a:xfrm>
+          <a:prstGeom prst="rect">
+            <a:avLst/>
+          </a:prstGeom>
+          <a:noFill/>
+          <a:ln/>
+        </p:spPr>
+        <p:txBody>
+          <a:bodyPr wrap="square" lIns="0" tIns="0" rIns="0" bIns="0" rtlCol="0" anchor="t"/>
+          <a:lstStyle/>
+          <a:p>
+            <a:pPr indent="0" marL="0">
+              <a:lnSpc>
+                <a:spcPct val="125000"/>
+              </a:lnSpc>
+              <a:spcAft>
+                <a:spcPts val="1600"/>
+              </a:spcAft>
+              <a:buNone/>
+            </a:pPr>
+            <a:r>
+              <a:rPr lang="en-US" sz="1700" b="1" dirty="0">
+                <a:solidFill>
+                  <a:srgbClr val="1F4E79"/>
+                </a:solidFill>
+                <a:latin typeface="Yu Gothic" pitchFamily="34" charset="0"/>
+                <a:ea typeface="Yu Gothic" pitchFamily="34" charset="-122"/>
+                <a:cs typeface="Yu Gothic" pitchFamily="34" charset="-120"/>
+              </a:rPr>
+              <a:t>1. </a:t>
+            </a:r>
+            <a:pPr indent="0" marL="0">
+              <a:lnSpc>
+                <a:spcPct val="125000"/>
+              </a:lnSpc>
+              <a:spcAft>
+                <a:spcPts val="1600"/>
+              </a:spcAft>
+              <a:buNone/>
+            </a:pPr>
+            <a:r>
+              <a:rPr lang="en-US" sz="1700" dirty="0">
+                <a:solidFill>
+                  <a:srgbClr val="2D2D2D"/>
+                </a:solidFill>
+                <a:latin typeface="Yu Gothic" pitchFamily="34" charset="0"/>
+                <a:ea typeface="Yu Gothic" pitchFamily="34" charset="-122"/>
+                <a:cs typeface="Yu Gothic" pitchFamily="34" charset="-120"/>
+              </a:rPr>
+              <a:t>Whisper の損失で学習した音声強調は、作りの違う認識器では</a:t>
+            </a:r>
+            <a:pPr indent="0" marL="0">
+              <a:lnSpc>
+                <a:spcPct val="125000"/>
+              </a:lnSpc>
+              <a:spcAft>
+                <a:spcPts val="1600"/>
+              </a:spcAft>
+              <a:buNone/>
+            </a:pPr>
+            <a:r>
+              <a:rPr lang="en-US" sz="1700" b="1" dirty="0">
+                <a:solidFill>
+                  <a:srgbClr val="C55A11"/>
+                </a:solidFill>
+                <a:latin typeface="Yu Gothic" pitchFamily="34" charset="0"/>
+                <a:ea typeface="Yu Gothic" pitchFamily="34" charset="-122"/>
+                <a:cs typeface="Yu Gothic" pitchFamily="34" charset="-120"/>
+              </a:rPr>
+              <a:t>逆に悪化</a:t>
+            </a:r>
+            <a:endParaRPr lang="en-US" sz="1700" dirty="0"/>
+          </a:p>
+          <a:p>
+            <a:pPr indent="0" marL="0">
+              <a:lnSpc>
+                <a:spcPct val="125000"/>
+              </a:lnSpc>
+              <a:spcAft>
+                <a:spcPts val="1600"/>
+              </a:spcAft>
+              <a:buNone/>
+            </a:pPr>
+            <a:r>
+              <a:rPr lang="en-US" sz="1700" b="1" dirty="0">
+                <a:solidFill>
+                  <a:srgbClr val="1F4E79"/>
+                </a:solidFill>
+                <a:latin typeface="Yu Gothic" pitchFamily="34" charset="0"/>
+                <a:ea typeface="Yu Gothic" pitchFamily="34" charset="-122"/>
+                <a:cs typeface="Yu Gothic" pitchFamily="34" charset="-120"/>
+              </a:rPr>
+              <a:t>2. </a:t>
+            </a:r>
+            <a:pPr indent="0" marL="0">
+              <a:lnSpc>
+                <a:spcPct val="125000"/>
+              </a:lnSpc>
+              <a:spcAft>
+                <a:spcPts val="1600"/>
+              </a:spcAft>
+              <a:buNone/>
+            </a:pPr>
+            <a:r>
+              <a:rPr lang="en-US" sz="1700" dirty="0">
+                <a:solidFill>
+                  <a:srgbClr val="2D2D2D"/>
+                </a:solidFill>
+                <a:latin typeface="Yu Gothic" pitchFamily="34" charset="0"/>
+                <a:ea typeface="Yu Gothic" pitchFamily="34" charset="-122"/>
+                <a:cs typeface="Yu Gothic" pitchFamily="34" charset="-120"/>
+              </a:rPr>
+              <a:t>事前学習済みの生成モデルは、</a:t>
+            </a:r>
+            <a:pPr indent="0" marL="0">
+              <a:lnSpc>
+                <a:spcPct val="125000"/>
+              </a:lnSpc>
+              <a:spcAft>
+                <a:spcPts val="1600"/>
+              </a:spcAft>
+              <a:buNone/>
+            </a:pPr>
+            <a:r>
+              <a:rPr lang="en-US" sz="1700" b="1" dirty="0">
+                <a:solidFill>
+                  <a:srgbClr val="2D2D2D"/>
+                </a:solidFill>
+                <a:latin typeface="Yu Gothic" pitchFamily="34" charset="0"/>
+                <a:ea typeface="Yu Gothic" pitchFamily="34" charset="-122"/>
+                <a:cs typeface="Yu Gothic" pitchFamily="34" charset="-120"/>
+              </a:rPr>
+              <a:t>どの認識器にも効く</a:t>
+            </a:r>
+            <a:endParaRPr lang="en-US" sz="1700" dirty="0"/>
+          </a:p>
+          <a:p>
+            <a:pPr indent="0" marL="0">
+              <a:lnSpc>
+                <a:spcPct val="125000"/>
+              </a:lnSpc>
+              <a:spcAft>
+                <a:spcPts val="1600"/>
+              </a:spcAft>
+              <a:buNone/>
+            </a:pPr>
+            <a:r>
+              <a:rPr lang="en-US" sz="1700" b="1" dirty="0">
+                <a:solidFill>
+                  <a:srgbClr val="1F4E79"/>
+                </a:solidFill>
+                <a:latin typeface="Yu Gothic" pitchFamily="34" charset="0"/>
+                <a:ea typeface="Yu Gothic" pitchFamily="34" charset="-122"/>
+                <a:cs typeface="Yu Gothic" pitchFamily="34" charset="-120"/>
+              </a:rPr>
+              <a:t>3. </a:t>
+            </a:r>
+            <a:pPr indent="0" marL="0">
+              <a:lnSpc>
+                <a:spcPct val="125000"/>
+              </a:lnSpc>
+              <a:spcAft>
+                <a:spcPts val="1600"/>
+              </a:spcAft>
+              <a:buNone/>
+            </a:pPr>
+            <a:r>
+              <a:rPr lang="en-US" sz="1700" dirty="0">
+                <a:solidFill>
+                  <a:srgbClr val="2D2D2D"/>
+                </a:solidFill>
+                <a:latin typeface="Yu Gothic" pitchFamily="34" charset="0"/>
+                <a:ea typeface="Yu Gothic" pitchFamily="34" charset="-122"/>
+                <a:cs typeface="Yu Gothic" pitchFamily="34" charset="-120"/>
+              </a:rPr>
+              <a:t>効くのは声の大まかな形。害は</a:t>
+            </a:r>
+            <a:pPr indent="0" marL="0">
+              <a:lnSpc>
+                <a:spcPct val="125000"/>
+              </a:lnSpc>
+              <a:spcAft>
+                <a:spcPts val="1600"/>
+              </a:spcAft>
+              <a:buNone/>
+            </a:pPr>
+            <a:r>
+              <a:rPr lang="en-US" sz="1700" b="1" dirty="0">
+                <a:solidFill>
+                  <a:srgbClr val="2D2D2D"/>
+                </a:solidFill>
+                <a:latin typeface="Yu Gothic" pitchFamily="34" charset="0"/>
+                <a:ea typeface="Yu Gothic" pitchFamily="34" charset="-122"/>
+                <a:cs typeface="Yu Gothic" pitchFamily="34" charset="-120"/>
+              </a:rPr>
+              <a:t>元々無い高い音</a:t>
+            </a:r>
+            <a:pPr indent="0" marL="0">
+              <a:lnSpc>
+                <a:spcPct val="125000"/>
+              </a:lnSpc>
+              <a:spcAft>
+                <a:spcPts val="1600"/>
+              </a:spcAft>
+              <a:buNone/>
+            </a:pPr>
+            <a:r>
+              <a:rPr lang="en-US" sz="1700" dirty="0">
+                <a:solidFill>
+                  <a:srgbClr val="2D2D2D"/>
+                </a:solidFill>
+                <a:latin typeface="Yu Gothic" pitchFamily="34" charset="0"/>
+                <a:ea typeface="Yu Gothic" pitchFamily="34" charset="-122"/>
+                <a:cs typeface="Yu Gothic" pitchFamily="34" charset="-120"/>
+              </a:rPr>
+              <a:t>から</a:t>
+            </a:r>
+            <a:endParaRPr lang="en-US" sz="1700" dirty="0"/>
+          </a:p>
+        </p:txBody>
+      </p:sp>
+      <p:sp>
+        <p:nvSpPr>
+          <p:cNvPr id="5" name="Shape 3"/>
+          <p:cNvSpPr/>
+          <p:nvPr/>
+        </p:nvSpPr>
+        <p:spPr>
+          <a:xfrm>
+            <a:off x="6355080" y="1554480"/>
+            <a:ext cx="0" cy="2743200"/>
+          </a:xfrm>
+          <a:prstGeom prst="line">
+            <a:avLst/>
+          </a:prstGeom>
+          <a:noFill/>
+          <a:ln w="12700">
+            <a:solidFill>
+              <a:srgbClr val="CCCCCC"/>
+            </a:solidFill>
+            <a:prstDash val="solid"/>
+          </a:ln>
+        </p:spPr>
+      </p:sp>
+      <p:sp>
+        <p:nvSpPr>
+          <p:cNvPr id="6" name="Text 4"/>
+          <p:cNvSpPr/>
+          <p:nvPr/>
+        </p:nvSpPr>
+        <p:spPr>
+          <a:xfrm>
+            <a:off x="6675120" y="1463040"/>
+            <a:ext cx="4967935" cy="411480"/>
+          </a:xfrm>
+          <a:prstGeom prst="rect">
+            <a:avLst/>
+          </a:prstGeom>
+          <a:noFill/>
+          <a:ln/>
+        </p:spPr>
+        <p:txBody>
+          <a:bodyPr wrap="square" lIns="0" tIns="0" rIns="0" bIns="0" rtlCol="0" anchor="t"/>
+          <a:lstStyle/>
+          <a:p>
+            <a:pPr indent="0" marL="0">
+              <a:buNone/>
+            </a:pPr>
+            <a:r>
+              <a:rPr lang="en-US" sz="2000" b="1" dirty="0">
+                <a:solidFill>
+                  <a:srgbClr val="1F4E79"/>
+                </a:solidFill>
+                <a:latin typeface="Yu Gothic" pitchFamily="34" charset="0"/>
+                <a:ea typeface="Yu Gothic" pitchFamily="34" charset="-122"/>
+                <a:cs typeface="Yu Gothic" pitchFamily="34" charset="-120"/>
+              </a:rPr>
+              <a:t>この研究の価値</a:t>
+            </a:r>
+            <a:endParaRPr lang="en-US" sz="2000" dirty="0"/>
+          </a:p>
+        </p:txBody>
+      </p:sp>
+      <p:sp>
+        <p:nvSpPr>
+          <p:cNvPr id="7" name="Text 5"/>
+          <p:cNvSpPr/>
+          <p:nvPr/>
+        </p:nvSpPr>
+        <p:spPr>
+          <a:xfrm>
+            <a:off x="6675120" y="1965960"/>
+            <a:ext cx="4967935" cy="3291840"/>
+          </a:xfrm>
+          <a:prstGeom prst="rect">
+            <a:avLst/>
+          </a:prstGeom>
+          <a:noFill/>
+          <a:ln/>
+        </p:spPr>
+        <p:txBody>
+          <a:bodyPr wrap="square" lIns="0" tIns="0" rIns="0" bIns="0" rtlCol="0" anchor="t"/>
+          <a:lstStyle/>
+          <a:p>
+            <a:pPr marL="228600" indent="-228600">
+              <a:lnSpc>
+                <a:spcPct val="125000"/>
+              </a:lnSpc>
+              <a:spcAft>
+                <a:spcPts val="1600"/>
+              </a:spcAft>
+              <a:buSzPct val="100000"/>
+              <a:buChar char="•"/>
+            </a:pPr>
+            <a:r>
+              <a:rPr lang="en-US" sz="1700" b="1" dirty="0">
+                <a:solidFill>
+                  <a:srgbClr val="2D2D2D"/>
+                </a:solidFill>
+                <a:latin typeface="Yu Gothic" pitchFamily="34" charset="0"/>
+                <a:ea typeface="Yu Gothic" pitchFamily="34" charset="-122"/>
+                <a:cs typeface="Yu Gothic" pitchFamily="34" charset="-120"/>
+              </a:rPr>
+              <a:t>中身を変えられない Whisper 系</a:t>
+            </a:r>
+            <a:pPr indent="0" marL="0">
+              <a:lnSpc>
+                <a:spcPct val="125000"/>
+              </a:lnSpc>
+              <a:spcAft>
+                <a:spcPts val="1600"/>
+              </a:spcAft>
+              <a:buNone/>
+            </a:pPr>
+            <a:r>
+              <a:rPr lang="en-US" sz="1700" dirty="0">
+                <a:solidFill>
+                  <a:srgbClr val="2D2D2D"/>
+                </a:solidFill>
+                <a:latin typeface="Yu Gothic" pitchFamily="34" charset="0"/>
+                <a:ea typeface="Yu Gothic" pitchFamily="34" charset="-122"/>
+                <a:cs typeface="Yu Gothic" pitchFamily="34" charset="-120"/>
+              </a:rPr>
+              <a:t>でも、前処理だけで誤りを 26〜37% 減らせる</a:t>
+            </a:r>
+            <a:endParaRPr lang="en-US" sz="1700" dirty="0"/>
+          </a:p>
+          <a:p>
+            <a:pPr marL="228600" indent="-228600">
+              <a:lnSpc>
+                <a:spcPct val="125000"/>
+              </a:lnSpc>
+              <a:spcAft>
+                <a:spcPts val="1600"/>
+              </a:spcAft>
+              <a:buSzPct val="100000"/>
+              <a:buChar char="•"/>
+            </a:pPr>
+            <a:r>
+              <a:rPr lang="en-US" sz="1700" b="1" dirty="0">
+                <a:solidFill>
+                  <a:srgbClr val="2D2D2D"/>
+                </a:solidFill>
+                <a:latin typeface="Yu Gothic" pitchFamily="34" charset="0"/>
+                <a:ea typeface="Yu Gothic" pitchFamily="34" charset="-122"/>
+                <a:cs typeface="Yu Gothic" pitchFamily="34" charset="-120"/>
+              </a:rPr>
+              <a:t>設計の指針</a:t>
+            </a:r>
+            <a:pPr indent="0" marL="0">
+              <a:lnSpc>
+                <a:spcPct val="125000"/>
+              </a:lnSpc>
+              <a:spcAft>
+                <a:spcPts val="1600"/>
+              </a:spcAft>
+              <a:buNone/>
+            </a:pPr>
+            <a:r>
+              <a:rPr lang="en-US" sz="1700" dirty="0">
+                <a:solidFill>
+                  <a:srgbClr val="2D2D2D"/>
+                </a:solidFill>
+                <a:latin typeface="Yu Gothic" pitchFamily="34" charset="0"/>
+                <a:ea typeface="Yu Gothic" pitchFamily="34" charset="-122"/>
+                <a:cs typeface="Yu Gothic" pitchFamily="34" charset="-120"/>
+              </a:rPr>
+              <a:t>：欠けた音は生成で補い、Whisper 向けの調整は外側で控えめに足す</a:t>
+            </a:r>
+            <a:endParaRPr lang="en-US" sz="1700" dirty="0"/>
+          </a:p>
+          <a:p>
+            <a:pPr marL="228600" indent="-228600">
+              <a:lnSpc>
+                <a:spcPct val="125000"/>
+              </a:lnSpc>
+              <a:spcAft>
+                <a:spcPts val="1600"/>
+              </a:spcAft>
+              <a:buSzPct val="100000"/>
+              <a:buChar char="•"/>
+            </a:pPr>
+            <a:r>
+              <a:rPr lang="en-US" sz="1700" dirty="0">
+                <a:solidFill>
+                  <a:srgbClr val="2D2D2D"/>
+                </a:solidFill>
+                <a:latin typeface="Yu Gothic" pitchFamily="34" charset="0"/>
+                <a:ea typeface="Yu Gothic" pitchFamily="34" charset="-122"/>
+                <a:cs typeface="Yu Gothic" pitchFamily="34" charset="-120"/>
+              </a:rPr>
+              <a:t>機種が変わると効かない</a:t>
+            </a:r>
+            <a:pPr indent="0" marL="0">
+              <a:lnSpc>
+                <a:spcPct val="125000"/>
+              </a:lnSpc>
+              <a:spcAft>
+                <a:spcPts val="1600"/>
+              </a:spcAft>
+              <a:buNone/>
+            </a:pPr>
+            <a:r>
+              <a:rPr lang="en-US" sz="1700" b="1" dirty="0">
+                <a:solidFill>
+                  <a:srgbClr val="2D2D2D"/>
+                </a:solidFill>
+                <a:latin typeface="Yu Gothic" pitchFamily="34" charset="0"/>
+                <a:ea typeface="Yu Gothic" pitchFamily="34" charset="-122"/>
+                <a:cs typeface="Yu Gothic" pitchFamily="34" charset="-120"/>
+              </a:rPr>
+              <a:t>限界</a:t>
+            </a:r>
+            <a:pPr indent="0" marL="0">
+              <a:lnSpc>
+                <a:spcPct val="125000"/>
+              </a:lnSpc>
+              <a:spcAft>
+                <a:spcPts val="1600"/>
+              </a:spcAft>
+              <a:buNone/>
+            </a:pPr>
+            <a:r>
+              <a:rPr lang="en-US" sz="1700" dirty="0">
+                <a:solidFill>
+                  <a:srgbClr val="2D2D2D"/>
+                </a:solidFill>
+                <a:latin typeface="Yu Gothic" pitchFamily="34" charset="0"/>
+                <a:ea typeface="Yu Gothic" pitchFamily="34" charset="-122"/>
+                <a:cs typeface="Yu Gothic" pitchFamily="34" charset="-120"/>
+              </a:rPr>
+              <a:t>も示した</a:t>
+            </a:r>
+            <a:endParaRPr lang="en-US" sz="1700" dirty="0"/>
+          </a:p>
+        </p:txBody>
+      </p:sp>
+      <p:sp>
+        <p:nvSpPr>
+          <p:cNvPr id="8" name="Text 6"/>
+          <p:cNvSpPr/>
+          <p:nvPr/>
+        </p:nvSpPr>
+        <p:spPr>
+          <a:xfrm>
+            <a:off x="548640" y="6309360"/>
+            <a:ext cx="11094415" cy="320040"/>
+          </a:xfrm>
+          <a:prstGeom prst="rect">
+            <a:avLst/>
+          </a:prstGeom>
+          <a:noFill/>
+          <a:ln/>
+        </p:spPr>
+        <p:txBody>
+          <a:bodyPr wrap="square" lIns="0" tIns="0" rIns="0" bIns="0" rtlCol="0" anchor="t"/>
+          <a:lstStyle/>
+          <a:p>
+            <a:pPr indent="0" marL="0">
+              <a:buNone/>
+            </a:pPr>
+            <a:r>
+              <a:rPr lang="en-US" sz="1200" dirty="0">
+                <a:solidFill>
+                  <a:srgbClr val="777777"/>
+                </a:solidFill>
+                <a:latin typeface="Yu Gothic" pitchFamily="34" charset="0"/>
+                <a:ea typeface="Yu Gothic" pitchFamily="34" charset="-122"/>
+                <a:cs typeface="Yu Gothic" pitchFamily="34" charset="-120"/>
+              </a:rPr>
+              <a:t>中身を変えられない認識器 = クラウドの音声認識など。限界は別機種の喉マイク（VibraVox、仏語）での確認による</a:t>
+            </a:r>
+            <a:endParaRPr lang="en-US" sz="1200" dirty="0"/>
+          </a:p>
+        </p:txBody>
+      </p:sp>
+    </p:spTree>
+  </p:cSld>
+  <p:clrMapOvr>
+    <a:masterClrMapping/>
+  </p:clrMapOvr>
+</p:sld>
+</file>
+
 <file path=ppt/theme/theme1.xml><?xml version="1.0" encoding="utf-8"?>
 <a:theme xmlns:a="http://schemas.openxmlformats.org/drawingml/2006/main" name="Office Theme">
   <a:themeElements>

</xml_diff>

<commit_message>
Fusion deck slide 4: cleaner findings/value, detail on envelope and high-band harm
Co-Authored-By: Claude Opus 5.5 (1M context) <noreply@anthropic.com>
</commit_message>
<xml_diff>
--- a/results/fusion_slides_2026-10.pptx
+++ b/results/fusion_slides_2026-10.pptx
@@ -1243,9 +1243,13 @@
           <a:p>
             <a:r>
               <a:rPr lang="en-US" dirty="0"/>
-              <a:t>【台本】（約40秒）
-この研究で分かったことは3つです。1つ目、Whisper の損失で学習した音声強調は、作りの違う認識器では逆に悪くなります。2つ目、事前学習済みの生成モデルは、どの認識器でも効きます。3つ目、Whisper に効いているのは声の大まかな形で、悪影響は喉マイクに元々無い高い音から来ています。
-価値としては、クラウドのように中身を変えられない Whisper 系の認識器でも、前処理だけで誤りを 26〜37% 減らせることです。また、欠けた音は生成で補い、Whisper 向けの調整は外側で控えめに足す、という設計の指針になります。一方で、別の機種の喉マイクではそのままでは効かないという限界も分かりました。</a:t>
+              <a:t>【台本】（約50秒）
+この研究で分かったことは4つです。
+1つ目、Whisper の損失で学習した音声強調は、作りの違う認識器では逆に誤りが 26〜46% 増えます。
+2つ目、事前学習済みの生成モデルは、9つの認識器すべてで誤りを 15〜24% 減らします。効いているのは事前学習の知識です。
+3つ目、混ぜたときに Whisper に効いているのは、声の大まかな形、つまり母音などを決める周波数の山の形です。細かい倍音の部分だけ混ぜても効きませんでした。
+4つ目、他の認識器への悪影響は、喉マイクに元々無い 4 kHz 以上の音を、Whisper 向けに作ってしまった成分から来ています。4 kHz 未満だけを混ぜれば悪影響は出ません。
+価値としては、クラウドのように中身を変えられない Whisper 系の認識器でも、前処理だけで誤りを 26〜37% 減らせること、そして、欠けた音は生成で補い、Whisper 向けの調整は外側で控えめに足す、という設計の指針になることです。ただし、別の機種の喉マイクにはそのままでは効かないという限界もあります。</a:t>
             </a:r>
             <a:endParaRPr lang="en-US" dirty="0"/>
           </a:p>
@@ -4310,8 +4314,8 @@
         </p:nvSpPr>
         <p:spPr>
           <a:xfrm>
-            <a:off x="548640" y="1463040"/>
-            <a:ext cx="5486400" cy="411480"/>
+            <a:off x="548640" y="1417320"/>
+            <a:ext cx="6035040" cy="365760"/>
           </a:xfrm>
           <a:prstGeom prst="rect">
             <a:avLst/>
@@ -4327,7 +4331,7 @@
               <a:buNone/>
             </a:pPr>
             <a:r>
-              <a:rPr lang="en-US" sz="2000" b="1" dirty="0">
+              <a:rPr lang="en-US" sz="1900" b="1" dirty="0">
                 <a:solidFill>
                   <a:srgbClr val="1F4E79"/>
                 </a:solidFill>
@@ -4337,7 +4341,7 @@
               </a:rPr>
               <a:t>分かったこと</a:t>
             </a:r>
-            <a:endParaRPr lang="en-US" sz="2000" dirty="0"/>
+            <a:endParaRPr lang="en-US" sz="1900" dirty="0"/>
           </a:p>
         </p:txBody>
       </p:sp>
@@ -4349,8 +4353,8 @@
         </p:nvSpPr>
         <p:spPr>
           <a:xfrm>
-            <a:off x="548640" y="1965960"/>
-            <a:ext cx="5486400" cy="3291840"/>
+            <a:off x="548640" y="1874520"/>
+            <a:ext cx="6035040" cy="365760"/>
           </a:xfrm>
           <a:prstGeom prst="rect">
             <a:avLst/>
@@ -4363,12 +4367,6 @@
           <a:lstStyle/>
           <a:p>
             <a:pPr indent="0" marL="0">
-              <a:lnSpc>
-                <a:spcPct val="125000"/>
-              </a:lnSpc>
-              <a:spcAft>
-                <a:spcPts val="1600"/>
-              </a:spcAft>
               <a:buNone/>
             </a:pPr>
             <a:r>
@@ -4382,17 +4380,106 @@
               </a:rPr>
               <a:t>1. </a:t>
             </a:r>
+            <a:pPr indent="0" marL="0">
+              <a:buNone/>
+            </a:pPr>
+            <a:r>
+              <a:rPr lang="en-US" sz="1700" b="1" dirty="0">
+                <a:solidFill>
+                  <a:srgbClr val="2D2D2D"/>
+                </a:solidFill>
+                <a:latin typeface="Yu Gothic" pitchFamily="34" charset="0"/>
+                <a:ea typeface="Yu Gothic" pitchFamily="34" charset="-122"/>
+                <a:cs typeface="Yu Gothic" pitchFamily="34" charset="-120"/>
+              </a:rPr>
+              <a:t>Whisper 用に学習すると、他の認識器では悪化</a:t>
+            </a:r>
+            <a:endParaRPr lang="en-US" sz="1700" dirty="0"/>
+          </a:p>
+        </p:txBody>
+      </p:sp>
+      <p:sp>
+        <p:nvSpPr>
+          <p:cNvPr id="5" name="Text 3"/>
+          <p:cNvSpPr/>
+          <p:nvPr/>
+        </p:nvSpPr>
+        <p:spPr>
+          <a:xfrm>
+            <a:off x="822960" y="2258568"/>
+            <a:ext cx="5760720" cy="274320"/>
+          </a:xfrm>
+          <a:prstGeom prst="rect">
+            <a:avLst/>
+          </a:prstGeom>
+          <a:noFill/>
+          <a:ln/>
+        </p:spPr>
+        <p:txBody>
+          <a:bodyPr wrap="square" lIns="0" tIns="0" rIns="0" bIns="0" rtlCol="0" anchor="t"/>
+          <a:lstStyle/>
+          <a:p>
             <a:pPr indent="0" marL="0">
               <a:lnSpc>
-                <a:spcPct val="125000"/>
+                <a:spcPct val="115000"/>
               </a:lnSpc>
-              <a:spcAft>
-                <a:spcPts val="1600"/>
-              </a:spcAft>
               <a:buNone/>
             </a:pPr>
             <a:r>
-              <a:rPr lang="en-US" sz="1700" dirty="0">
+              <a:rPr lang="en-US" sz="1400" dirty="0">
+                <a:solidFill>
+                  <a:srgbClr val="777777"/>
+                </a:solidFill>
+                <a:latin typeface="Yu Gothic" pitchFamily="34" charset="0"/>
+                <a:ea typeface="Yu Gothic" pitchFamily="34" charset="-122"/>
+                <a:cs typeface="Yu Gothic" pitchFamily="34" charset="-120"/>
+              </a:rPr>
+              <a:t>作りの違う XLS-R・Zipformer では誤りが 26〜46% 増える</a:t>
+            </a:r>
+            <a:endParaRPr lang="en-US" sz="1400" dirty="0"/>
+          </a:p>
+        </p:txBody>
+      </p:sp>
+      <p:sp>
+        <p:nvSpPr>
+          <p:cNvPr id="6" name="Text 4"/>
+          <p:cNvSpPr/>
+          <p:nvPr/>
+        </p:nvSpPr>
+        <p:spPr>
+          <a:xfrm>
+            <a:off x="548640" y="2825496"/>
+            <a:ext cx="6035040" cy="365760"/>
+          </a:xfrm>
+          <a:prstGeom prst="rect">
+            <a:avLst/>
+          </a:prstGeom>
+          <a:noFill/>
+          <a:ln/>
+        </p:spPr>
+        <p:txBody>
+          <a:bodyPr wrap="square" lIns="0" tIns="0" rIns="0" bIns="0" rtlCol="0" anchor="t"/>
+          <a:lstStyle/>
+          <a:p>
+            <a:pPr indent="0" marL="0">
+              <a:buNone/>
+            </a:pPr>
+            <a:r>
+              <a:rPr lang="en-US" sz="1700" b="1" dirty="0">
+                <a:solidFill>
+                  <a:srgbClr val="1F4E79"/>
+                </a:solidFill>
+                <a:latin typeface="Yu Gothic" pitchFamily="34" charset="0"/>
+                <a:ea typeface="Yu Gothic" pitchFamily="34" charset="-122"/>
+                <a:cs typeface="Yu Gothic" pitchFamily="34" charset="-120"/>
+              </a:rPr>
+              <a:t>2. </a:t>
+            </a:r>
+            <a:pPr indent="0" marL="0">
+              <a:buNone/>
+            </a:pPr>
+            <a:r>
+              <a:rPr lang="en-US" sz="1700" b="1" dirty="0">
                 <a:solidFill>
                   <a:srgbClr val="2D2D2D"/>
                 </a:solidFill>
@@ -4400,62 +4487,209 @@
                 <a:ea typeface="Yu Gothic" pitchFamily="34" charset="-122"/>
                 <a:cs typeface="Yu Gothic" pitchFamily="34" charset="-120"/>
               </a:rPr>
-              <a:t>Whisper の損失で学習した音声強調は、作りの違う認識器では</a:t>
-            </a:r>
+              <a:t>生成モデルは、どの認識器にも効く</a:t>
+            </a:r>
+            <a:endParaRPr lang="en-US" sz="1700" dirty="0"/>
+          </a:p>
+        </p:txBody>
+      </p:sp>
+      <p:sp>
+        <p:nvSpPr>
+          <p:cNvPr id="7" name="Text 5"/>
+          <p:cNvSpPr/>
+          <p:nvPr/>
+        </p:nvSpPr>
+        <p:spPr>
+          <a:xfrm>
+            <a:off x="822960" y="3209544"/>
+            <a:ext cx="5760720" cy="274320"/>
+          </a:xfrm>
+          <a:prstGeom prst="rect">
+            <a:avLst/>
+          </a:prstGeom>
+          <a:noFill/>
+          <a:ln/>
+        </p:spPr>
+        <p:txBody>
+          <a:bodyPr wrap="square" lIns="0" tIns="0" rIns="0" bIns="0" rtlCol="0" anchor="t"/>
+          <a:lstStyle/>
+          <a:p>
             <a:pPr indent="0" marL="0">
               <a:lnSpc>
-                <a:spcPct val="125000"/>
+                <a:spcPct val="115000"/>
               </a:lnSpc>
-              <a:spcAft>
-                <a:spcPts val="1600"/>
-              </a:spcAft>
               <a:buNone/>
             </a:pPr>
             <a:r>
+              <a:rPr lang="en-US" sz="1400" dirty="0">
+                <a:solidFill>
+                  <a:srgbClr val="777777"/>
+                </a:solidFill>
+                <a:latin typeface="Yu Gothic" pitchFamily="34" charset="0"/>
+                <a:ea typeface="Yu Gothic" pitchFamily="34" charset="-122"/>
+                <a:cs typeface="Yu Gothic" pitchFamily="34" charset="-120"/>
+              </a:rPr>
+              <a:t>9つすべてで誤りが 15〜24% 減る。効果の源は事前学習</a:t>
+            </a:r>
+            <a:endParaRPr lang="en-US" sz="1400" dirty="0"/>
+          </a:p>
+        </p:txBody>
+      </p:sp>
+      <p:sp>
+        <p:nvSpPr>
+          <p:cNvPr id="8" name="Text 6"/>
+          <p:cNvSpPr/>
+          <p:nvPr/>
+        </p:nvSpPr>
+        <p:spPr>
+          <a:xfrm>
+            <a:off x="548640" y="3776472"/>
+            <a:ext cx="6035040" cy="365760"/>
+          </a:xfrm>
+          <a:prstGeom prst="rect">
+            <a:avLst/>
+          </a:prstGeom>
+          <a:noFill/>
+          <a:ln/>
+        </p:spPr>
+        <p:txBody>
+          <a:bodyPr wrap="square" lIns="0" tIns="0" rIns="0" bIns="0" rtlCol="0" anchor="t"/>
+          <a:lstStyle/>
+          <a:p>
+            <a:pPr indent="0" marL="0">
+              <a:buNone/>
+            </a:pPr>
+            <a:r>
               <a:rPr lang="en-US" sz="1700" b="1" dirty="0">
                 <a:solidFill>
-                  <a:srgbClr val="C55A11"/>
-                </a:solidFill>
-                <a:latin typeface="Yu Gothic" pitchFamily="34" charset="0"/>
-                <a:ea typeface="Yu Gothic" pitchFamily="34" charset="-122"/>
-                <a:cs typeface="Yu Gothic" pitchFamily="34" charset="-120"/>
-              </a:rPr>
-              <a:t>逆に悪化</a:t>
+                  <a:srgbClr val="1F4E79"/>
+                </a:solidFill>
+                <a:latin typeface="Yu Gothic" pitchFamily="34" charset="0"/>
+                <a:ea typeface="Yu Gothic" pitchFamily="34" charset="-122"/>
+                <a:cs typeface="Yu Gothic" pitchFamily="34" charset="-120"/>
+              </a:rPr>
+              <a:t>3. </a:t>
+            </a:r>
+            <a:pPr indent="0" marL="0">
+              <a:buNone/>
+            </a:pPr>
+            <a:r>
+              <a:rPr lang="en-US" sz="1700" b="1" dirty="0">
+                <a:solidFill>
+                  <a:srgbClr val="2D2D2D"/>
+                </a:solidFill>
+                <a:latin typeface="Yu Gothic" pitchFamily="34" charset="0"/>
+                <a:ea typeface="Yu Gothic" pitchFamily="34" charset="-122"/>
+                <a:cs typeface="Yu Gothic" pitchFamily="34" charset="-120"/>
+              </a:rPr>
+              <a:t>Whisper に効くのは「声の大まかな形」</a:t>
             </a:r>
             <a:endParaRPr lang="en-US" sz="1700" dirty="0"/>
           </a:p>
+        </p:txBody>
+      </p:sp>
+      <p:sp>
+        <p:nvSpPr>
+          <p:cNvPr id="9" name="Text 7"/>
+          <p:cNvSpPr/>
+          <p:nvPr/>
+        </p:nvSpPr>
+        <p:spPr>
+          <a:xfrm>
+            <a:off x="822960" y="4160520"/>
+            <a:ext cx="5760720" cy="548640"/>
+          </a:xfrm>
+          <a:prstGeom prst="rect">
+            <a:avLst/>
+          </a:prstGeom>
+          <a:noFill/>
+          <a:ln/>
+        </p:spPr>
+        <p:txBody>
+          <a:bodyPr wrap="square" lIns="0" tIns="0" rIns="0" bIns="0" rtlCol="0" anchor="t"/>
+          <a:lstStyle/>
           <a:p>
             <a:pPr indent="0" marL="0">
               <a:lnSpc>
-                <a:spcPct val="125000"/>
+                <a:spcPct val="115000"/>
               </a:lnSpc>
-              <a:spcAft>
-                <a:spcPts val="1600"/>
-              </a:spcAft>
               <a:buNone/>
             </a:pPr>
             <a:r>
-              <a:rPr lang="en-US" sz="1700" b="1" dirty="0">
-                <a:solidFill>
-                  <a:srgbClr val="1F4E79"/>
-                </a:solidFill>
-                <a:latin typeface="Yu Gothic" pitchFamily="34" charset="0"/>
-                <a:ea typeface="Yu Gothic" pitchFamily="34" charset="-122"/>
-                <a:cs typeface="Yu Gothic" pitchFamily="34" charset="-120"/>
-              </a:rPr>
-              <a:t>2. </a:t>
-            </a:r>
+              <a:rPr lang="en-US" sz="1400" dirty="0">
+                <a:solidFill>
+                  <a:srgbClr val="777777"/>
+                </a:solidFill>
+                <a:latin typeface="Yu Gothic" pitchFamily="34" charset="0"/>
+                <a:ea typeface="Yu Gothic" pitchFamily="34" charset="-122"/>
+                <a:cs typeface="Yu Gothic" pitchFamily="34" charset="-120"/>
+              </a:rPr>
+              <a:t>母音などを決める周波数の山の形（スペクトル包絡）。</a:t>
+            </a:r>
+            <a:endParaRPr lang="en-US" sz="1400" dirty="0"/>
+          </a:p>
+          <a:p>
             <a:pPr indent="0" marL="0">
               <a:lnSpc>
-                <a:spcPct val="125000"/>
+                <a:spcPct val="115000"/>
               </a:lnSpc>
-              <a:spcAft>
-                <a:spcPts val="1600"/>
-              </a:spcAft>
               <a:buNone/>
             </a:pPr>
             <a:r>
-              <a:rPr lang="en-US" sz="1700" dirty="0">
+              <a:rPr lang="en-US" sz="1400" dirty="0">
+                <a:solidFill>
+                  <a:srgbClr val="777777"/>
+                </a:solidFill>
+                <a:latin typeface="Yu Gothic" pitchFamily="34" charset="0"/>
+                <a:ea typeface="Yu Gothic" pitchFamily="34" charset="-122"/>
+                <a:cs typeface="Yu Gothic" pitchFamily="34" charset="-120"/>
+              </a:rPr>
+              <a:t>細かい倍音だけ混ぜても効かない</a:t>
+            </a:r>
+            <a:endParaRPr lang="en-US" sz="1400" dirty="0"/>
+          </a:p>
+        </p:txBody>
+      </p:sp>
+      <p:sp>
+        <p:nvSpPr>
+          <p:cNvPr id="10" name="Text 8"/>
+          <p:cNvSpPr/>
+          <p:nvPr/>
+        </p:nvSpPr>
+        <p:spPr>
+          <a:xfrm>
+            <a:off x="548640" y="5001768"/>
+            <a:ext cx="6035040" cy="365760"/>
+          </a:xfrm>
+          <a:prstGeom prst="rect">
+            <a:avLst/>
+          </a:prstGeom>
+          <a:noFill/>
+          <a:ln/>
+        </p:spPr>
+        <p:txBody>
+          <a:bodyPr wrap="square" lIns="0" tIns="0" rIns="0" bIns="0" rtlCol="0" anchor="t"/>
+          <a:lstStyle/>
+          <a:p>
+            <a:pPr indent="0" marL="0">
+              <a:buNone/>
+            </a:pPr>
+            <a:r>
+              <a:rPr lang="en-US" sz="1700" b="1" dirty="0">
+                <a:solidFill>
+                  <a:srgbClr val="1F4E79"/>
+                </a:solidFill>
+                <a:latin typeface="Yu Gothic" pitchFamily="34" charset="0"/>
+                <a:ea typeface="Yu Gothic" pitchFamily="34" charset="-122"/>
+                <a:cs typeface="Yu Gothic" pitchFamily="34" charset="-120"/>
+              </a:rPr>
+              <a:t>4. </a:t>
+            </a:r>
+            <a:pPr indent="0" marL="0">
+              <a:buNone/>
+            </a:pPr>
+            <a:r>
+              <a:rPr lang="en-US" sz="1700" b="1" dirty="0">
                 <a:solidFill>
                   <a:srgbClr val="2D2D2D"/>
                 </a:solidFill>
@@ -4463,125 +4697,84 @@
                 <a:ea typeface="Yu Gothic" pitchFamily="34" charset="-122"/>
                 <a:cs typeface="Yu Gothic" pitchFamily="34" charset="-120"/>
               </a:rPr>
-              <a:t>事前学習済みの生成モデルは、</a:t>
-            </a:r>
+              <a:t>他の認識器への害は「元々無い高い音」から</a:t>
+            </a:r>
+            <a:endParaRPr lang="en-US" sz="1700" dirty="0"/>
+          </a:p>
+        </p:txBody>
+      </p:sp>
+      <p:sp>
+        <p:nvSpPr>
+          <p:cNvPr id="11" name="Text 9"/>
+          <p:cNvSpPr/>
+          <p:nvPr/>
+        </p:nvSpPr>
+        <p:spPr>
+          <a:xfrm>
+            <a:off x="822960" y="5385816"/>
+            <a:ext cx="5760720" cy="548640"/>
+          </a:xfrm>
+          <a:prstGeom prst="rect">
+            <a:avLst/>
+          </a:prstGeom>
+          <a:noFill/>
+          <a:ln/>
+        </p:spPr>
+        <p:txBody>
+          <a:bodyPr wrap="square" lIns="0" tIns="0" rIns="0" bIns="0" rtlCol="0" anchor="t"/>
+          <a:lstStyle/>
+          <a:p>
             <a:pPr indent="0" marL="0">
               <a:lnSpc>
-                <a:spcPct val="125000"/>
+                <a:spcPct val="115000"/>
               </a:lnSpc>
-              <a:spcAft>
-                <a:spcPts val="1600"/>
-              </a:spcAft>
               <a:buNone/>
             </a:pPr>
             <a:r>
-              <a:rPr lang="en-US" sz="1700" b="1" dirty="0">
-                <a:solidFill>
-                  <a:srgbClr val="2D2D2D"/>
-                </a:solidFill>
-                <a:latin typeface="Yu Gothic" pitchFamily="34" charset="0"/>
-                <a:ea typeface="Yu Gothic" pitchFamily="34" charset="-122"/>
-                <a:cs typeface="Yu Gothic" pitchFamily="34" charset="-120"/>
-              </a:rPr>
-              <a:t>どの認識器にも効く</a:t>
-            </a:r>
-            <a:endParaRPr lang="en-US" sz="1700" dirty="0"/>
+              <a:rPr lang="en-US" sz="1400" dirty="0">
+                <a:solidFill>
+                  <a:srgbClr val="777777"/>
+                </a:solidFill>
+                <a:latin typeface="Yu Gothic" pitchFamily="34" charset="0"/>
+                <a:ea typeface="Yu Gothic" pitchFamily="34" charset="-122"/>
+                <a:cs typeface="Yu Gothic" pitchFamily="34" charset="-120"/>
+              </a:rPr>
+              <a:t>喉マイクに無い 4 kHz 以上を Whisper 向けに作った成分。</a:t>
+            </a:r>
+            <a:endParaRPr lang="en-US" sz="1400" dirty="0"/>
           </a:p>
           <a:p>
             <a:pPr indent="0" marL="0">
               <a:lnSpc>
-                <a:spcPct val="125000"/>
+                <a:spcPct val="115000"/>
               </a:lnSpc>
-              <a:spcAft>
-                <a:spcPts val="1600"/>
-              </a:spcAft>
               <a:buNone/>
             </a:pPr>
             <a:r>
-              <a:rPr lang="en-US" sz="1700" b="1" dirty="0">
-                <a:solidFill>
-                  <a:srgbClr val="1F4E79"/>
-                </a:solidFill>
-                <a:latin typeface="Yu Gothic" pitchFamily="34" charset="0"/>
-                <a:ea typeface="Yu Gothic" pitchFamily="34" charset="-122"/>
-                <a:cs typeface="Yu Gothic" pitchFamily="34" charset="-120"/>
-              </a:rPr>
-              <a:t>3. </a:t>
-            </a:r>
-            <a:pPr indent="0" marL="0">
-              <a:lnSpc>
-                <a:spcPct val="125000"/>
-              </a:lnSpc>
-              <a:spcAft>
-                <a:spcPts val="1600"/>
-              </a:spcAft>
-              <a:buNone/>
-            </a:pPr>
-            <a:r>
-              <a:rPr lang="en-US" sz="1700" dirty="0">
-                <a:solidFill>
-                  <a:srgbClr val="2D2D2D"/>
-                </a:solidFill>
-                <a:latin typeface="Yu Gothic" pitchFamily="34" charset="0"/>
-                <a:ea typeface="Yu Gothic" pitchFamily="34" charset="-122"/>
-                <a:cs typeface="Yu Gothic" pitchFamily="34" charset="-120"/>
-              </a:rPr>
-              <a:t>効くのは声の大まかな形。害は</a:t>
-            </a:r>
-            <a:pPr indent="0" marL="0">
-              <a:lnSpc>
-                <a:spcPct val="125000"/>
-              </a:lnSpc>
-              <a:spcAft>
-                <a:spcPts val="1600"/>
-              </a:spcAft>
-              <a:buNone/>
-            </a:pPr>
-            <a:r>
-              <a:rPr lang="en-US" sz="1700" b="1" dirty="0">
-                <a:solidFill>
-                  <a:srgbClr val="2D2D2D"/>
-                </a:solidFill>
-                <a:latin typeface="Yu Gothic" pitchFamily="34" charset="0"/>
-                <a:ea typeface="Yu Gothic" pitchFamily="34" charset="-122"/>
-                <a:cs typeface="Yu Gothic" pitchFamily="34" charset="-120"/>
-              </a:rPr>
-              <a:t>元々無い高い音</a:t>
-            </a:r>
-            <a:pPr indent="0" marL="0">
-              <a:lnSpc>
-                <a:spcPct val="125000"/>
-              </a:lnSpc>
-              <a:spcAft>
-                <a:spcPts val="1600"/>
-              </a:spcAft>
-              <a:buNone/>
-            </a:pPr>
-            <a:r>
-              <a:rPr lang="en-US" sz="1700" dirty="0">
-                <a:solidFill>
-                  <a:srgbClr val="2D2D2D"/>
-                </a:solidFill>
-                <a:latin typeface="Yu Gothic" pitchFamily="34" charset="0"/>
-                <a:ea typeface="Yu Gothic" pitchFamily="34" charset="-122"/>
-                <a:cs typeface="Yu Gothic" pitchFamily="34" charset="-120"/>
-              </a:rPr>
-              <a:t>から</a:t>
-            </a:r>
-            <a:endParaRPr lang="en-US" sz="1700" dirty="0"/>
+              <a:rPr lang="en-US" sz="1400" dirty="0">
+                <a:solidFill>
+                  <a:srgbClr val="777777"/>
+                </a:solidFill>
+                <a:latin typeface="Yu Gothic" pitchFamily="34" charset="0"/>
+                <a:ea typeface="Yu Gothic" pitchFamily="34" charset="-122"/>
+                <a:cs typeface="Yu Gothic" pitchFamily="34" charset="-120"/>
+              </a:rPr>
+              <a:t>4 kHz 未満だけ混ぜれば害は出ない</a:t>
+            </a:r>
+            <a:endParaRPr lang="en-US" sz="1400" dirty="0"/>
           </a:p>
         </p:txBody>
       </p:sp>
       <p:sp>
         <p:nvSpPr>
-          <p:cNvPr id="5" name="Shape 3"/>
+          <p:cNvPr id="12" name="Shape 10"/>
           <p:cNvSpPr/>
           <p:nvPr/>
         </p:nvSpPr>
         <p:spPr>
           <a:xfrm>
-            <a:off x="6355080" y="1554480"/>
-            <a:ext cx="0" cy="2743200"/>
+            <a:off x="6903720" y="1508760"/>
+            <a:ext cx="0" cy="4297680"/>
           </a:xfrm>
           <a:prstGeom prst="line">
             <a:avLst/>
@@ -4597,14 +4790,14 @@
       </p:sp>
       <p:sp>
         <p:nvSpPr>
-          <p:cNvPr id="6" name="Text 4"/>
+          <p:cNvPr id="13" name="Text 11"/>
           <p:cNvSpPr/>
           <p:nvPr/>
         </p:nvSpPr>
         <p:spPr>
           <a:xfrm>
-            <a:off x="6675120" y="1463040"/>
-            <a:ext cx="4967935" cy="411480"/>
+            <a:off x="7223760" y="1417320"/>
+            <a:ext cx="4419295" cy="365760"/>
           </a:xfrm>
           <a:prstGeom prst="rect">
             <a:avLst/>
@@ -4620,7 +4813,7 @@
               <a:buNone/>
             </a:pPr>
             <a:r>
-              <a:rPr lang="en-US" sz="2000" b="1" dirty="0">
+              <a:rPr lang="en-US" sz="1900" b="1" dirty="0">
                 <a:solidFill>
                   <a:srgbClr val="1F4E79"/>
                 </a:solidFill>
@@ -4630,20 +4823,20 @@
               </a:rPr>
               <a:t>この研究の価値</a:t>
             </a:r>
-            <a:endParaRPr lang="en-US" sz="2000" dirty="0"/>
+            <a:endParaRPr lang="en-US" sz="1900" dirty="0"/>
           </a:p>
         </p:txBody>
       </p:sp>
       <p:sp>
         <p:nvSpPr>
-          <p:cNvPr id="7" name="Text 5"/>
+          <p:cNvPr id="14" name="Text 12"/>
           <p:cNvSpPr/>
           <p:nvPr/>
         </p:nvSpPr>
         <p:spPr>
           <a:xfrm>
-            <a:off x="6675120" y="1965960"/>
-            <a:ext cx="4967935" cy="3291840"/>
+            <a:off x="7223760" y="1874520"/>
+            <a:ext cx="4419295" cy="365760"/>
           </a:xfrm>
           <a:prstGeom prst="rect">
             <a:avLst/>
@@ -4655,15 +4848,8 @@
           <a:bodyPr wrap="square" lIns="0" tIns="0" rIns="0" bIns="0" rtlCol="0" anchor="t"/>
           <a:lstStyle/>
           <a:p>
-            <a:pPr marL="228600" indent="-228600">
-              <a:lnSpc>
-                <a:spcPct val="125000"/>
-              </a:lnSpc>
-              <a:spcAft>
-                <a:spcPts val="1600"/>
-              </a:spcAft>
-              <a:buSzPct val="100000"/>
-              <a:buChar char="•"/>
+            <a:pPr indent="0" marL="0">
+              <a:buNone/>
             </a:pPr>
             <a:r>
               <a:rPr lang="en-US" sz="1700" b="1" dirty="0">
@@ -4674,63 +4860,100 @@
                 <a:ea typeface="Yu Gothic" pitchFamily="34" charset="-122"/>
                 <a:cs typeface="Yu Gothic" pitchFamily="34" charset="-120"/>
               </a:rPr>
-              <a:t>中身を変えられない Whisper 系</a:t>
-            </a:r>
+              <a:t>前処理だけで誤り 26〜37% 減</a:t>
+            </a:r>
+            <a:endParaRPr lang="en-US" sz="1700" dirty="0"/>
+          </a:p>
+        </p:txBody>
+      </p:sp>
+      <p:sp>
+        <p:nvSpPr>
+          <p:cNvPr id="15" name="Text 13"/>
+          <p:cNvSpPr/>
+          <p:nvPr/>
+        </p:nvSpPr>
+        <p:spPr>
+          <a:xfrm>
+            <a:off x="7223760" y="2258568"/>
+            <a:ext cx="4419295" cy="731520"/>
+          </a:xfrm>
+          <a:prstGeom prst="rect">
+            <a:avLst/>
+          </a:prstGeom>
+          <a:noFill/>
+          <a:ln/>
+        </p:spPr>
+        <p:txBody>
+          <a:bodyPr wrap="square" lIns="0" tIns="0" rIns="0" bIns="0" rtlCol="0" anchor="t"/>
+          <a:lstStyle/>
+          <a:p>
             <a:pPr indent="0" marL="0">
               <a:lnSpc>
-                <a:spcPct val="125000"/>
+                <a:spcPct val="115000"/>
               </a:lnSpc>
-              <a:spcAft>
-                <a:spcPts val="1600"/>
-              </a:spcAft>
               <a:buNone/>
             </a:pPr>
             <a:r>
-              <a:rPr lang="en-US" sz="1700" dirty="0">
-                <a:solidFill>
-                  <a:srgbClr val="2D2D2D"/>
-                </a:solidFill>
-                <a:latin typeface="Yu Gothic" pitchFamily="34" charset="0"/>
-                <a:ea typeface="Yu Gothic" pitchFamily="34" charset="-122"/>
-                <a:cs typeface="Yu Gothic" pitchFamily="34" charset="-120"/>
-              </a:rPr>
-              <a:t>でも、前処理だけで誤りを 26〜37% 減らせる</a:t>
-            </a:r>
-            <a:endParaRPr lang="en-US" sz="1700" dirty="0"/>
-          </a:p>
-          <a:p>
-            <a:pPr marL="228600" indent="-228600">
-              <a:lnSpc>
-                <a:spcPct val="125000"/>
-              </a:lnSpc>
-              <a:spcAft>
-                <a:spcPts val="1600"/>
-              </a:spcAft>
-              <a:buSzPct val="100000"/>
-              <a:buChar char="•"/>
-            </a:pPr>
-            <a:r>
-              <a:rPr lang="en-US" sz="1700" b="1" dirty="0">
-                <a:solidFill>
-                  <a:srgbClr val="2D2D2D"/>
-                </a:solidFill>
-                <a:latin typeface="Yu Gothic" pitchFamily="34" charset="0"/>
-                <a:ea typeface="Yu Gothic" pitchFamily="34" charset="-122"/>
-                <a:cs typeface="Yu Gothic" pitchFamily="34" charset="-120"/>
-              </a:rPr>
-              <a:t>設計の指針</a:t>
-            </a:r>
+              <a:rPr lang="en-US" sz="1400" dirty="0">
+                <a:solidFill>
+                  <a:srgbClr val="777777"/>
+                </a:solidFill>
+                <a:latin typeface="Yu Gothic" pitchFamily="34" charset="0"/>
+                <a:ea typeface="Yu Gothic" pitchFamily="34" charset="-122"/>
+                <a:cs typeface="Yu Gothic" pitchFamily="34" charset="-120"/>
+              </a:rPr>
+              <a:t>クラウドの認識器など、中身を変えられない</a:t>
+            </a:r>
+            <a:endParaRPr lang="en-US" sz="1400" dirty="0"/>
+          </a:p>
+          <a:p>
             <a:pPr indent="0" marL="0">
               <a:lnSpc>
-                <a:spcPct val="125000"/>
+                <a:spcPct val="115000"/>
               </a:lnSpc>
-              <a:spcAft>
-                <a:spcPts val="1600"/>
-              </a:spcAft>
               <a:buNone/>
             </a:pPr>
             <a:r>
-              <a:rPr lang="en-US" sz="1700" dirty="0">
+              <a:rPr lang="en-US" sz="1400" dirty="0">
+                <a:solidFill>
+                  <a:srgbClr val="777777"/>
+                </a:solidFill>
+                <a:latin typeface="Yu Gothic" pitchFamily="34" charset="0"/>
+                <a:ea typeface="Yu Gothic" pitchFamily="34" charset="-122"/>
+                <a:cs typeface="Yu Gothic" pitchFamily="34" charset="-120"/>
+              </a:rPr>
+              <a:t>Whisper 系にも使える</a:t>
+            </a:r>
+            <a:endParaRPr lang="en-US" sz="1400" dirty="0"/>
+          </a:p>
+        </p:txBody>
+      </p:sp>
+      <p:sp>
+        <p:nvSpPr>
+          <p:cNvPr id="16" name="Text 14"/>
+          <p:cNvSpPr/>
+          <p:nvPr/>
+        </p:nvSpPr>
+        <p:spPr>
+          <a:xfrm>
+            <a:off x="7223760" y="3154680"/>
+            <a:ext cx="4419295" cy="365760"/>
+          </a:xfrm>
+          <a:prstGeom prst="rect">
+            <a:avLst/>
+          </a:prstGeom>
+          <a:noFill/>
+          <a:ln/>
+        </p:spPr>
+        <p:txBody>
+          <a:bodyPr wrap="square" lIns="0" tIns="0" rIns="0" bIns="0" rtlCol="0" anchor="t"/>
+          <a:lstStyle/>
+          <a:p>
+            <a:pPr indent="0" marL="0">
+              <a:buNone/>
+            </a:pPr>
+            <a:r>
+              <a:rPr lang="en-US" sz="1700" b="1" dirty="0">
                 <a:solidFill>
                   <a:srgbClr val="2D2D2D"/>
                 </a:solidFill>
@@ -4738,79 +4961,77 @@
                 <a:ea typeface="Yu Gothic" pitchFamily="34" charset="-122"/>
                 <a:cs typeface="Yu Gothic" pitchFamily="34" charset="-120"/>
               </a:rPr>
-              <a:t>：欠けた音は生成で補い、Whisper 向けの調整は外側で控えめに足す</a:t>
+              <a:t>設計の指針になる</a:t>
             </a:r>
             <a:endParaRPr lang="en-US" sz="1700" dirty="0"/>
           </a:p>
-          <a:p>
-            <a:pPr marL="228600" indent="-228600">
-              <a:lnSpc>
-                <a:spcPct val="125000"/>
-              </a:lnSpc>
-              <a:spcAft>
-                <a:spcPts val="1600"/>
-              </a:spcAft>
-              <a:buSzPct val="100000"/>
-              <a:buChar char="•"/>
-            </a:pPr>
-            <a:r>
-              <a:rPr lang="en-US" sz="1700" dirty="0">
-                <a:solidFill>
-                  <a:srgbClr val="2D2D2D"/>
-                </a:solidFill>
-                <a:latin typeface="Yu Gothic" pitchFamily="34" charset="0"/>
-                <a:ea typeface="Yu Gothic" pitchFamily="34" charset="-122"/>
-                <a:cs typeface="Yu Gothic" pitchFamily="34" charset="-120"/>
-              </a:rPr>
-              <a:t>機種が変わると効かない</a:t>
-            </a:r>
+        </p:txBody>
+      </p:sp>
+      <p:sp>
+        <p:nvSpPr>
+          <p:cNvPr id="17" name="Text 15"/>
+          <p:cNvSpPr/>
+          <p:nvPr/>
+        </p:nvSpPr>
+        <p:spPr>
+          <a:xfrm>
+            <a:off x="7223760" y="3538728"/>
+            <a:ext cx="4419295" cy="731520"/>
+          </a:xfrm>
+          <a:prstGeom prst="rect">
+            <a:avLst/>
+          </a:prstGeom>
+          <a:noFill/>
+          <a:ln/>
+        </p:spPr>
+        <p:txBody>
+          <a:bodyPr wrap="square" lIns="0" tIns="0" rIns="0" bIns="0" rtlCol="0" anchor="t"/>
+          <a:lstStyle/>
+          <a:p>
             <a:pPr indent="0" marL="0">
               <a:lnSpc>
-                <a:spcPct val="125000"/>
+                <a:spcPct val="115000"/>
               </a:lnSpc>
-              <a:spcAft>
-                <a:spcPts val="1600"/>
-              </a:spcAft>
               <a:buNone/>
             </a:pPr>
             <a:r>
-              <a:rPr lang="en-US" sz="1700" b="1" dirty="0">
-                <a:solidFill>
-                  <a:srgbClr val="2D2D2D"/>
-                </a:solidFill>
-                <a:latin typeface="Yu Gothic" pitchFamily="34" charset="0"/>
-                <a:ea typeface="Yu Gothic" pitchFamily="34" charset="-122"/>
-                <a:cs typeface="Yu Gothic" pitchFamily="34" charset="-120"/>
-              </a:rPr>
-              <a:t>限界</a:t>
-            </a:r>
+              <a:rPr lang="en-US" sz="1400" dirty="0">
+                <a:solidFill>
+                  <a:srgbClr val="777777"/>
+                </a:solidFill>
+                <a:latin typeface="Yu Gothic" pitchFamily="34" charset="0"/>
+                <a:ea typeface="Yu Gothic" pitchFamily="34" charset="-122"/>
+                <a:cs typeface="Yu Gothic" pitchFamily="34" charset="-120"/>
+              </a:rPr>
+              <a:t>欠けた音は生成モデルで補い、</a:t>
+            </a:r>
+            <a:endParaRPr lang="en-US" sz="1400" dirty="0"/>
+          </a:p>
+          <a:p>
             <a:pPr indent="0" marL="0">
               <a:lnSpc>
-                <a:spcPct val="125000"/>
+                <a:spcPct val="115000"/>
               </a:lnSpc>
-              <a:spcAft>
-                <a:spcPts val="1600"/>
-              </a:spcAft>
               <a:buNone/>
             </a:pPr>
             <a:r>
-              <a:rPr lang="en-US" sz="1700" dirty="0">
-                <a:solidFill>
-                  <a:srgbClr val="2D2D2D"/>
-                </a:solidFill>
-                <a:latin typeface="Yu Gothic" pitchFamily="34" charset="0"/>
-                <a:ea typeface="Yu Gothic" pitchFamily="34" charset="-122"/>
-                <a:cs typeface="Yu Gothic" pitchFamily="34" charset="-120"/>
-              </a:rPr>
-              <a:t>も示した</a:t>
-            </a:r>
-            <a:endParaRPr lang="en-US" sz="1700" dirty="0"/>
+              <a:rPr lang="en-US" sz="1400" dirty="0">
+                <a:solidFill>
+                  <a:srgbClr val="777777"/>
+                </a:solidFill>
+                <a:latin typeface="Yu Gothic" pitchFamily="34" charset="0"/>
+                <a:ea typeface="Yu Gothic" pitchFamily="34" charset="-122"/>
+                <a:cs typeface="Yu Gothic" pitchFamily="34" charset="-120"/>
+              </a:rPr>
+              <a:t>Whisper 向けの調整は外側で控えめに足す</a:t>
+            </a:r>
+            <a:endParaRPr lang="en-US" sz="1400" dirty="0"/>
           </a:p>
         </p:txBody>
       </p:sp>
       <p:sp>
         <p:nvSpPr>
-          <p:cNvPr id="8" name="Text 6"/>
+          <p:cNvPr id="18" name="Text 16"/>
           <p:cNvSpPr/>
           <p:nvPr/>
         </p:nvSpPr>
@@ -4841,7 +5062,7 @@
                 <a:ea typeface="Yu Gothic" pitchFamily="34" charset="-122"/>
                 <a:cs typeface="Yu Gothic" pitchFamily="34" charset="-120"/>
               </a:rPr>
-              <a:t>中身を変えられない認識器 = クラウドの音声認識など。限界は別機種の喉マイク（VibraVox、仏語）での確認による</a:t>
+              <a:t>限界：TAPS で学習した部品は、別機種の喉マイク（VibraVox、仏語）にはそのままでは効かない（機種ごとの適応が必要）</a:t>
             </a:r>
             <a:endParaRPr lang="en-US" sz="1200" dirty="0"/>
           </a:p>

</xml_diff>